<commit_message>
Week 4 Thursday: the trainer files, the interview room and the sources list
- the day sheet with its module, date and faculty sync blocks, the envelope, the traps, the
  checkpoints, the handoff line and the fallback
- the run sheet for the case file with three reveals, its printed cards and the answer-key page
- the app team's lead's role card, the interview transcript with the AI-company variant, the
  scorecards and the dispute transcript, the Delhi Metro guesstimate, the lab note with the Kalpa
  hand count and plants, and the fallback note
- the sources list: every public fact re-fetched today, the case-file corrections, open items

Co-Authored-By: Claude Opus 5.5 <noreply@anthropic.com>
Claude-Session: https://claude.ai/code/session_01NPLds1PXr7nZqxdmBPv5HF
</commit_message>
<xml_diff>
--- a/content/W04/D4/slides/C2_W04_D04_half1_STUDENT.pptx
+++ b/content/W04/D4/slides/C2_W04_D04_half1_STUDENT.pptx
@@ -1081,7 +1081,12 @@
           </a:p>
           <a:p>
             <a:r>
-              <a:t>https://www.eternal.com/blog/q1fy27/ (checked 12 October 2026)</a:t>
+              <a:t>https://www.eternal.com/blog/q1fy27/ (checked 12 October 2026), which links the letter itself:</a:t>
+            </a:r>
+          </a:p>
+          <a:p>
+            <a:r>
+              <a:t>https://drive.google.com/file/d/1jb9KWd4Ap4RTKHFHxzEOO7jgQqVZEGcd/view (checked 12 October 2026)</a:t>
             </a:r>
           </a:p>
           <a:p>

</xml_diff>

<commit_message>
Week 4 Thursday: the notebooks define only check
Notebook 01 counts the card's two readings in a plain loop and the batch toy's blend inline, notebook
02 builds age from two month counts in place of a helper, and the lab's typed lines set the three
stretches without a lambda. All four notebooks re-executed cold; the age slide shows the same lines.

Co-Authored-By: Claude Opus 5.5 <noreply@anthropic.com>
Claude-Session: https://claude.ai/code/session_01NPLds1PXr7nZqxdmBPv5HF
</commit_message>
<xml_diff>
--- a/content/W04/D4/slides/C2_W04_D04_half1_STUDENT.pptx
+++ b/content/W04/D4/slides/C2_W04_D04_half1_STUDENT.pptx
@@ -1441,17 +1441,22 @@
           <a:lstStyle/>
           <a:p>
             <a:r>
-              <a:t>LIVE, 5 minutes. Read the code a line at a time: age as the gap in months, active as at least one</a:t>
-            </a:r>
-          </a:p>
-          <a:p>
-            <a:r>
-              <a:t>order, one pivot_table with cohorts on the rows and ages on the columns; each cell is a mean of</a:t>
-            </a:r>
-          </a:p>
-          <a:p>
-            <a:r>
-              <a:t>True and False, so it is a share. Vote before the cell runs.</a:t>
+              <a:t>LIVE, 5 minutes. Read the code a line at a time: each year-month as one count of months, age as</a:t>
+            </a:r>
+          </a:p>
+          <a:p>
+            <a:r>
+              <a:t>the gap between the two, then one pivot_table with cohorts on the rows and ages on the columns;</a:t>
+            </a:r>
+          </a:p>
+          <a:p>
+            <a:r>
+              <a:t>active (at least one order) was set when the table loaded, and each cell is a mean of True and</a:t>
+            </a:r>
+          </a:p>
+          <a:p>
+            <a:r>
+              <a:t>False, so it is a share. Vote before the cell runs.</a:t>
             </a:r>
           </a:p>
           <a:p>
@@ -16135,7 +16140,7 @@
                 </a:solidFill>
                 <a:latin typeface="Consolas"/>
               </a:rPr>
-              <a:t>to_n = lambda s: s.str[:4].astype(int) * 12 + s.str[5:].astype(int)</a:t>
+              <a:t>month_n = mm["month"].str[:4].astype(int) * 12 + mm["month"].str[5:].astype(int)</a:t>
             </a:r>
           </a:p>
           <a:p>
@@ -16151,7 +16156,7 @@
                 </a:solidFill>
                 <a:latin typeface="Consolas"/>
               </a:rPr>
-              <a:t>mm["age"] = to_n(mm["month"]) - to_n(mm["cohort_month"])   # month zero is the joining month</a:t>
+              <a:t>cohort_n = mm["cohort_month"].str[:4].astype(int) * 12 + mm["cohort_month"].str[5:].astype(int)</a:t>
             </a:r>
           </a:p>
           <a:p>
@@ -16167,7 +16172,7 @@
                 </a:solidFill>
                 <a:latin typeface="Consolas"/>
               </a:rPr>
-              <a:t>mm["active"] = mm["orders"] &gt; 0</a:t>
+              <a:t>mm["age"] = month_n - cohort_n          # month zero is the joining month</a:t>
             </a:r>
           </a:p>
           <a:p>

</xml_diff>

<commit_message>
Week 4 Thursday: the card's August line reads 0 of 5
The card's five sale-week members are now the four with no September order and a fifth drawn the
same way, so the hand count no longer equals the sale-week members' own 19.8 percent and the card's
September count, 2 of 12, sits clear of Kalpa's per-member checkout. Only the twelve-row file
changes; every other data file is byte-identical, and every file that quoted the card follows.

Co-Authored-By: Claude Opus 5.5 <noreply@anthropic.com>
Claude-Session: https://claude.ai/code/session_01NPLds1PXr7nZqxdmBPv5HF
</commit_message>
<xml_diff>
--- a/content/W04/D4/slides/C2_W04_D04_half1_STUDENT.pptx
+++ b/content/W04/D4/slides/C2_W04_D04_half1_STUDENT.pptx
@@ -1381,7 +1381,7 @@
           </a:p>
           <a:p>
             <a:r>
-              <a:t>carries it in: each group fell with age, the sale-week members kept 1 of 5, and the dashboard's way</a:t>
+              <a:t>carries it in: each group fell with age, the sale-week members kept 0 of 5, and the dashboard's way</a:t>
             </a:r>
           </a:p>
           <a:p>
@@ -3876,12 +3876,12 @@
           </a:p>
           <a:p>
             <a:r>
-              <a:t>in May, ordered in June and July, then stopped. The last line holds four sale-week members, named</a:t>
-            </a:r>
-          </a:p>
-          <a:p>
-            <a:r>
-              <a:t>one by one, none of whom ordered in September. Ask each table to rewrite the card by months since joining instead of by</a:t>
+              <a:t>in May, ordered in June and July, then stopped. The last line holds the five sale-week members,</a:t>
+            </a:r>
+          </a:p>
+          <a:p>
+            <a:r>
+              <a:t>named one by one, none of whom ordered in September. Ask each table to rewrite the card by months since joining instead of by</a:t>
             </a:r>
           </a:p>
           <a:p>
@@ -8265,7 +8265,7 @@
                 </a:solidFill>
                 <a:latin typeface="Georgia"/>
               </a:rPr>
-              <a:t>Answer: May 3 of 4, June 2 of 3, sale 1 of 5</a:t>
+              <a:t>Answer: May 3 of 4, June 2 of 3, sale 0 of 5</a:t>
             </a:r>
           </a:p>
         </p:txBody>
@@ -8691,7 +8691,7 @@
                           </a:solidFill>
                           <a:latin typeface="Calibri"/>
                         </a:rPr>
-                        <a:t>1 of 5</a:t>
+                        <a:t>0 of 5</a:t>
                       </a:r>
                     </a:p>
                   </a:txBody>
@@ -8776,7 +8776,7 @@
                 </a:solidFill>
                 <a:latin typeface="Calibri"/>
               </a:rPr>
-              <a:t>The answer is a. Each group falls as it ages, and each later group starts lower: 75, 67 and then 20 percent in month one. A </a:t>
+              <a:t>The answer is a. Each group falls as it ages, and each later group starts lower: 75, 67 and then 0 percent in month one. A </a:t>
             </a:r>
             <a:r>
               <a:rPr sz="1600" b="1" i="0">
@@ -9394,7 +9394,7 @@
                 </a:solidFill>
                 <a:latin typeface="Calibri"/>
               </a:rPr>
-              <a:t>d) 3 of 12 in both months</a:t>
+              <a:t>d) 2 of 12 in both months</a:t>
             </a:r>
           </a:p>
         </p:txBody>
@@ -10195,7 +10195,7 @@
                           </a:solidFill>
                           <a:latin typeface="Calibri"/>
                         </a:rPr>
-                        <a:t>3 of 12</a:t>
+                        <a:t>2 of 12</a:t>
                       </a:r>
                     </a:p>
                   </a:txBody>
@@ -10244,7 +10244,7 @@
                 </a:solidFill>
                 <a:latin typeface="Calibri"/>
               </a:rPr>
-              <a:t>The answer is b. The dashboard's way did not move from August to September, though five members joined in the sale week and four of them did not order: they are outside its count until October. Counted for everyone, September reads 3 of 12.</a:t>
+              <a:t>The answer is b. The dashboard's way did not move from August to September, though five members joined in the sale week and none of them ordered: they are outside its count until October. Counted for everyone, September reads 2 of 12.</a:t>
             </a:r>
           </a:p>
         </p:txBody>
@@ -12976,7 +12976,7 @@
       </p:sp>
       <p:pic>
         <p:nvPicPr>
-          <p:cNvPr id="9" name="mermaid diagram" descr="5b72f46379a9e272.png"/>
+          <p:cNvPr id="9" name="mermaid diagram" descr="51730f3559232a6a.png"/>
           <p:cNvPicPr>
             <a:picLocks noChangeAspect="1"/>
           </p:cNvPicPr>
@@ -38179,8 +38179,8 @@
           <p:nvPr/>
         </p:nvGraphicFramePr>
         <p:xfrm>
-          <a:off x="530352" y="1682496"/>
-          <a:ext cx="11130991" cy="3352800"/>
+          <a:off x="530352" y="1918208"/>
+          <a:ext cx="11130991" cy="3017520"/>
         </p:xfrm>
         <a:graphic>
           <a:graphicData uri="http://schemas.openxmlformats.org/drawingml/2006/table">
@@ -39458,7 +39458,7 @@
                           </a:solidFill>
                           <a:latin typeface="Calibri"/>
                         </a:rPr>
-                        <a:t>ZG38681</a:t>
+                        <a:t>ZG39559, ZG40539, ZG41000, ZG41529, ZG42328</a:t>
                       </a:r>
                     </a:p>
                   </a:txBody>
@@ -39570,7 +39570,7 @@
                           </a:solidFill>
                           <a:latin typeface="Calibri"/>
                         </a:rPr>
-                        <a:t>1</a:t>
+                        <a:t>0 each</a:t>
                       </a:r>
                     </a:p>
                   </a:txBody>
@@ -39581,142 +39581,6 @@
                   </a:tcPr>
                 </a:tc>
               </a:tr>
-              <a:tr h="335280">
-                <a:tc>
-                  <a:txBody>
-                    <a:bodyPr/>
-                    <a:lstStyle/>
-                    <a:p>
-                      <a:r>
-                        <a:rPr sz="1200" b="0" i="0">
-                          <a:solidFill>
-                            <a:srgbClr val="1A1440"/>
-                          </a:solidFill>
-                          <a:latin typeface="Calibri"/>
-                        </a:rPr>
-                        <a:t>ZG40539, ZG41000, ZG41529, ZG42328</a:t>
-                      </a:r>
-                    </a:p>
-                  </a:txBody>
-                  <a:tcPr marL="101600" marR="101600" marT="38100" marB="38100" anchor="ctr">
-                    <a:solidFill>
-                      <a:srgbClr val="FFFFFF"/>
-                    </a:solidFill>
-                  </a:tcPr>
-                </a:tc>
-                <a:tc>
-                  <a:txBody>
-                    <a:bodyPr/>
-                    <a:lstStyle/>
-                    <a:p>
-                      <a:r>
-                        <a:rPr sz="1200" b="0" i="0">
-                          <a:solidFill>
-                            <a:srgbClr val="1A1440"/>
-                          </a:solidFill>
-                          <a:latin typeface="Calibri"/>
-                        </a:rPr>
-                        <a:t>Aug</a:t>
-                      </a:r>
-                    </a:p>
-                  </a:txBody>
-                  <a:tcPr marL="101600" marR="101600" marT="38100" marB="38100" anchor="ctr">
-                    <a:solidFill>
-                      <a:srgbClr val="FFFFFF"/>
-                    </a:solidFill>
-                  </a:tcPr>
-                </a:tc>
-                <a:tc>
-                  <a:txBody>
-                    <a:bodyPr/>
-                    <a:lstStyle/>
-                    <a:p>
-                      <a:r>
-                        <a:rPr sz="1200" b="0" i="0">
-                          <a:solidFill>
-                            <a:srgbClr val="1A1440"/>
-                          </a:solidFill>
-                          <a:latin typeface="Calibri"/>
-                        </a:rPr>
-                        <a:t>sale</a:t>
-                      </a:r>
-                    </a:p>
-                  </a:txBody>
-                  <a:tcPr marL="101600" marR="101600" marT="38100" marB="38100" anchor="ctr">
-                    <a:solidFill>
-                      <a:srgbClr val="FFFFFF"/>
-                    </a:solidFill>
-                  </a:tcPr>
-                </a:tc>
-                <a:tc>
-                  <a:txBody>
-                    <a:bodyPr/>
-                    <a:lstStyle/>
-                    <a:p/>
-                  </a:txBody>
-                  <a:tcPr marL="101600" marR="101600" marT="38100" marB="38100" anchor="ctr">
-                    <a:solidFill>
-                      <a:srgbClr val="FFFFFF"/>
-                    </a:solidFill>
-                  </a:tcPr>
-                </a:tc>
-                <a:tc>
-                  <a:txBody>
-                    <a:bodyPr/>
-                    <a:lstStyle/>
-                    <a:p/>
-                  </a:txBody>
-                  <a:tcPr marL="101600" marR="101600" marT="38100" marB="38100" anchor="ctr">
-                    <a:solidFill>
-                      <a:srgbClr val="FFFFFF"/>
-                    </a:solidFill>
-                  </a:tcPr>
-                </a:tc>
-                <a:tc>
-                  <a:txBody>
-                    <a:bodyPr/>
-                    <a:lstStyle/>
-                    <a:p>
-                      <a:r>
-                        <a:rPr sz="1200" b="0" i="0">
-                          <a:solidFill>
-                            <a:srgbClr val="1A1440"/>
-                          </a:solidFill>
-                          <a:latin typeface="Calibri"/>
-                        </a:rPr>
-                        <a:t>joined</a:t>
-                      </a:r>
-                    </a:p>
-                  </a:txBody>
-                  <a:tcPr marL="101600" marR="101600" marT="38100" marB="38100" anchor="ctr">
-                    <a:solidFill>
-                      <a:srgbClr val="FFFFFF"/>
-                    </a:solidFill>
-                  </a:tcPr>
-                </a:tc>
-                <a:tc>
-                  <a:txBody>
-                    <a:bodyPr/>
-                    <a:lstStyle/>
-                    <a:p>
-                      <a:r>
-                        <a:rPr sz="1200" b="0" i="0">
-                          <a:solidFill>
-                            <a:srgbClr val="1A1440"/>
-                          </a:solidFill>
-                          <a:latin typeface="Calibri"/>
-                        </a:rPr>
-                        <a:t>0 each</a:t>
-                      </a:r>
-                    </a:p>
-                  </a:txBody>
-                  <a:tcPr marL="101600" marR="101600" marT="38100" marB="38100" anchor="ctr">
-                    <a:solidFill>
-                      <a:srgbClr val="FFFFFF"/>
-                    </a:solidFill>
-                  </a:tcPr>
-                </a:tc>
-              </a:tr>
             </a:tbl>
           </a:graphicData>
         </a:graphic>
@@ -39729,7 +39593,7 @@
         </p:nvSpPr>
         <p:spPr>
           <a:xfrm>
-            <a:off x="530352" y="5291328"/>
+            <a:off x="530352" y="5191760"/>
             <a:ext cx="11130991" cy="772160"/>
           </a:xfrm>
           <a:prstGeom prst="rect">

</xml_diff>

<commit_message>
Week 4 Thursday: the interviewer's re-score answered
The transcript's close apportions the drop (3.2 of 3.6 points is the August cohort) and says
retention cannot see the checkout; replies hand over the sale and the order value; the outside
causes split by member and platform; the break is placed on the member path; the AI variant checks
the week's model changes and reads curve shapes. The dispute transcript writes the interviewer's
replies and puts its count, held-fixed split and cost range in the main answer. The cost floor is
now counted in orders placed, 1,133 to 1,317 a week, across the pack and notebook 03, and Swiggy's
cohort index is fixed.

Co-Authored-By: Claude Opus 5.5 <noreply@anthropic.com>
Claude-Session: https://claude.ai/code/session_01NPLds1PXr7nZqxdmBPv5HF
</commit_message>
<xml_diff>
--- a/content/W04/D4/slides/C2_W04_D04_half1_STUDENT.pptx
+++ b/content/W04/D4/slides/C2_W04_D04_half1_STUDENT.pptx
@@ -11977,7 +11977,7 @@
         <p:spPr>
           <a:xfrm>
             <a:off x="530352" y="1956816"/>
-            <a:ext cx="5474055" cy="2534412"/>
+            <a:ext cx="5474055" cy="2724404"/>
           </a:xfrm>
           <a:prstGeom prst="roundRect">
             <a:avLst>
@@ -12204,7 +12204,7 @@
         <p:spPr>
           <a:xfrm>
             <a:off x="6187287" y="1956816"/>
-            <a:ext cx="5474055" cy="2534412"/>
+            <a:ext cx="5474055" cy="2724404"/>
           </a:xfrm>
           <a:prstGeom prst="roundRect">
             <a:avLst>
@@ -12382,7 +12382,7 @@
                 </a:solidFill>
                 <a:latin typeface="Calibri"/>
               </a:rPr>
-              <a:t>Spend by cohort, against the quarter it joined</a:t>
+              <a:t>Spend by cohort, indexed to one cohort's first quarter</a:t>
             </a:r>
           </a:p>
         </p:txBody>
@@ -12396,7 +12396,7 @@
         <p:spPr>
           <a:xfrm>
             <a:off x="6388455" y="3303524"/>
-            <a:ext cx="5071719" cy="944626"/>
+            <a:ext cx="5071719" cy="1126236"/>
           </a:xfrm>
           <a:prstGeom prst="rect">
             <a:avLst/>
@@ -12417,7 +12417,7 @@
                 </a:solidFill>
                 <a:latin typeface="Calibri"/>
               </a:rPr>
-              <a:t>The cohort that joined in Q4 FY24 (January to March 2024) spends 4.14 times in its sixth quarter what it spent in its first. Swiggy says it weaned away users with "low potential Lifetime values", withdrawing the offers that kept them, and the table states no denominator: per user who joined, or per user who stayed?</a:t>
+              <a:t>Every cohort's spend is shown against what the Q4 FY24 cohort (January to March 2024) spent in the quarter it joined, and that cohort spends 4.14 times as much in its sixth quarter. Swiggy says it weaned away users with "low potential Lifetime values", withdrawing the offers that kept them, and the table states no denominator: per user who joined, or per user who stayed?</a:t>
             </a:r>
           </a:p>
         </p:txBody>
@@ -12430,7 +12430,7 @@
         </p:nvSpPr>
         <p:spPr>
           <a:xfrm>
-            <a:off x="530352" y="4674108"/>
+            <a:off x="530352" y="4864100"/>
             <a:ext cx="11130991" cy="772160"/>
           </a:xfrm>
           <a:prstGeom prst="rect">
@@ -25128,7 +25128,7 @@
                 </a:solidFill>
                 <a:latin typeface="Georgia"/>
               </a:rPr>
-              <a:t>"It is both, in two numbers that need different fixes. Retention is a cohort problem: the dashboard starts counting at month two, where every cohort lands near 38.5, so it never sees that each new cohort starts lower in month one, and it has not yet counted the 13,000-member August cohort, whose sale-week members kept 20 percent; in October the dashboard drops to about 33. The order loss hits members of every signup month on Android at one step from the 14 September release: of the checkouts started, 72.5 percent ended in an order before and 55 after, about 1,223 to 1,317 orders a week. Fix the Android checkout first; before buying another sale, work out whether this one's members pay back their discount."</a:t>
+              <a:t>"It is both, in two numbers that need different fixes. Retention is a cohort problem: the dashboard starts counting at month two, where every cohort lands near 38.5, so it never sees that each new cohort starts lower in month one, and it has not yet counted the 13,000-member August cohort, whose sale-week members kept 20 percent; in October the dashboard drops to about 33. The order loss hits members of every signup month on Android at one step from the 14 September release: of the checkouts started, 72.5 percent ended in an order before and 55 after, about 1,133 to 1,317 orders a week. Fix the Android checkout first; before buying another sale, work out whether this one's members pay back their discount."</a:t>
             </a:r>
           </a:p>
         </p:txBody>
@@ -34827,7 +34827,7 @@
                 </a:solidFill>
                 <a:latin typeface="Calibri"/>
               </a:rPr>
-              <a:t>0.14 × 22,841 carts is about 3,198 orders in 17 days: 188 a day, 1,317 a week, or 1,223 net of the point the comparators also lost, about a quarter of Android members' 5,064 orders a week. At Rs 300 to Rs 500 an order (an assumption), Rs 3.7 to 6.6 lakh of order value a week, of which Zomato keeps its commission and fees.</a:t>
+              <a:t>0.14 × 22,841 carts is about 3,198 orders in 17 days: 188 a day, 1,317 a week if none came back; counted in orders placed, 1,133 to 1,266 a week, a quarter of Android members' 5,064. At Rs 300 to Rs 500 an order (an assumption), Rs 3.4 to 6.6 lakh of order value a week, of which Zomato keeps its commission and fees.</a:t>
             </a:r>
           </a:p>
         </p:txBody>

</xml_diff>

<commit_message>
Week 4 Thursday: the week map carries two short lines a node so it prints at a readable size
Slide two's map printed its labels at 8.3 points; each node now keeps its day, its company and the
number the room earned on it, on two lines.

Co-Authored-By: Claude Opus 5.5 <noreply@anthropic.com>
Claude-Session: https://claude.ai/code/session_01P7zaoR4dQ5pzBFnsX549JQ
</commit_message>
<xml_diff>
--- a/content/W04/D4/slides/C2_W04_D04_half1_STUDENT.pptx
+++ b/content/W04/D4/slides/C2_W04_D04_half1_STUDENT.pptx
@@ -12976,7 +12976,7 @@
       </p:sp>
       <p:pic>
         <p:nvPicPr>
-          <p:cNvPr id="9" name="mermaid diagram" descr="51730f3559232a6a.png"/>
+          <p:cNvPr id="9" name="mermaid diagram" descr="df5981e9478e2ad0.png"/>
           <p:cNvPicPr>
             <a:picLocks noChangeAspect="1"/>
           </p:cNvPicPr>
@@ -12990,8 +12990,8 @@
         </p:blipFill>
         <p:spPr>
           <a:xfrm>
-            <a:off x="530352" y="1682496"/>
-            <a:ext cx="11130991" cy="1243975"/>
+            <a:off x="921341" y="1664208"/>
+            <a:ext cx="10349012" cy="2295144"/>
           </a:xfrm>
           <a:prstGeom prst="rect">
             <a:avLst/>
@@ -13006,7 +13006,7 @@
         </p:nvSpPr>
         <p:spPr>
           <a:xfrm>
-            <a:off x="530352" y="3072775"/>
+            <a:off x="530352" y="4005072"/>
             <a:ext cx="11130991" cy="1380744"/>
           </a:xfrm>
           <a:prstGeom prst="roundRect">
@@ -13060,7 +13060,7 @@
         </p:nvSpPr>
         <p:spPr>
           <a:xfrm>
-            <a:off x="758952" y="3534547"/>
+            <a:off x="758952" y="4466844"/>
             <a:ext cx="457200" cy="457200"/>
           </a:xfrm>
           <a:prstGeom prst="ellipse">
@@ -13112,7 +13112,7 @@
         </p:blipFill>
         <p:spPr>
           <a:xfrm>
-            <a:off x="868680" y="3644275"/>
+            <a:off x="868680" y="4576572"/>
             <a:ext cx="237744" cy="237744"/>
           </a:xfrm>
           <a:prstGeom prst="rect">
@@ -13128,7 +13128,7 @@
         </p:nvSpPr>
         <p:spPr>
           <a:xfrm>
-            <a:off x="1399031" y="3219079"/>
+            <a:off x="1399031" y="4151376"/>
             <a:ext cx="9987991" cy="160401"/>
           </a:xfrm>
           <a:prstGeom prst="rect">
@@ -13163,7 +13163,7 @@
         </p:nvSpPr>
         <p:spPr>
           <a:xfrm>
-            <a:off x="1399031" y="3438535"/>
+            <a:off x="1399031" y="4370832"/>
             <a:ext cx="9987991" cy="941832"/>
           </a:xfrm>
           <a:prstGeom prst="rect">
@@ -13197,7 +13197,7 @@
         </p:nvSpPr>
         <p:spPr>
           <a:xfrm>
-            <a:off x="530352" y="4618111"/>
+            <a:off x="530352" y="5550408"/>
             <a:ext cx="11130991" cy="1380744"/>
           </a:xfrm>
           <a:prstGeom prst="roundRect">
@@ -13251,7 +13251,7 @@
         </p:nvSpPr>
         <p:spPr>
           <a:xfrm>
-            <a:off x="758952" y="5079883"/>
+            <a:off x="758952" y="6012180"/>
             <a:ext cx="457200" cy="457200"/>
           </a:xfrm>
           <a:prstGeom prst="ellipse">
@@ -13303,7 +13303,7 @@
         </p:blipFill>
         <p:spPr>
           <a:xfrm>
-            <a:off x="868680" y="5189611"/>
+            <a:off x="868680" y="6121908"/>
             <a:ext cx="237744" cy="237744"/>
           </a:xfrm>
           <a:prstGeom prst="rect">
@@ -13319,7 +13319,7 @@
         </p:nvSpPr>
         <p:spPr>
           <a:xfrm>
-            <a:off x="1399031" y="4764415"/>
+            <a:off x="1399031" y="5696712"/>
             <a:ext cx="9987991" cy="160401"/>
           </a:xfrm>
           <a:prstGeom prst="rect">
@@ -13354,7 +13354,7 @@
         </p:nvSpPr>
         <p:spPr>
           <a:xfrm>
-            <a:off x="1399031" y="4983871"/>
+            <a:off x="1399031" y="5916168"/>
             <a:ext cx="9987991" cy="941832"/>
           </a:xfrm>
           <a:prstGeom prst="rect">
@@ -14123,7 +14123,7 @@
                 </a:solidFill>
                 <a:latin typeface="Calibri"/>
               </a:rPr>
-              <a:t>Week 4 Day 4: who is leaving Zomato Gold, and at which step</a:t>
+              <a:t>Week 4, Day 4. Who is leaving Zomato Gold in Chennai, and at which step?</a:t>
             </a:r>
           </a:p>
         </p:txBody>
@@ -16821,7 +16821,7 @@
       </p:sp>
       <p:pic>
         <p:nvPicPr>
-          <p:cNvPr id="9" name="mermaid diagram" descr="6666cc6ddfa3b618.png"/>
+          <p:cNvPr id="9" name="mermaid diagram" descr="1e025ae40bea612b.png"/>
           <p:cNvPicPr>
             <a:picLocks noChangeAspect="1"/>
           </p:cNvPicPr>
@@ -16835,8 +16835,8 @@
         </p:blipFill>
         <p:spPr>
           <a:xfrm>
-            <a:off x="779525" y="1682496"/>
-            <a:ext cx="10632643" cy="4517136"/>
+            <a:off x="2682134" y="1682496"/>
+            <a:ext cx="6827426" cy="4517136"/>
           </a:xfrm>
           <a:prstGeom prst="rect">
             <a:avLst/>
@@ -23625,7 +23625,7 @@
       </p:sp>
       <p:pic>
         <p:nvPicPr>
-          <p:cNvPr id="9" name="mermaid diagram" descr="49d81dc46918aa92.png"/>
+          <p:cNvPr id="9" name="mermaid diagram" descr="4faa342654827e92.png"/>
           <p:cNvPicPr>
             <a:picLocks noChangeAspect="1"/>
           </p:cNvPicPr>
@@ -23639,8 +23639,8 @@
         </p:blipFill>
         <p:spPr>
           <a:xfrm>
-            <a:off x="530351" y="1937186"/>
-            <a:ext cx="11130991" cy="1453531"/>
+            <a:off x="1826879" y="1664208"/>
+            <a:ext cx="8537935" cy="2295144"/>
           </a:xfrm>
           <a:prstGeom prst="rect">
             <a:avLst/>
@@ -23655,7 +23655,7 @@
         </p:nvSpPr>
         <p:spPr>
           <a:xfrm>
-            <a:off x="530352" y="3537021"/>
+            <a:off x="530352" y="4005072"/>
             <a:ext cx="11130991" cy="1121664"/>
           </a:xfrm>
           <a:prstGeom prst="roundRect">
@@ -23709,7 +23709,7 @@
         </p:nvSpPr>
         <p:spPr>
           <a:xfrm>
-            <a:off x="758952" y="3869253"/>
+            <a:off x="758952" y="4337304"/>
             <a:ext cx="457200" cy="457200"/>
           </a:xfrm>
           <a:prstGeom prst="ellipse">
@@ -23761,7 +23761,7 @@
         </p:blipFill>
         <p:spPr>
           <a:xfrm>
-            <a:off x="868680" y="3978981"/>
+            <a:off x="868680" y="4447032"/>
             <a:ext cx="237744" cy="237744"/>
           </a:xfrm>
           <a:prstGeom prst="rect">
@@ -23777,7 +23777,7 @@
         </p:nvSpPr>
         <p:spPr>
           <a:xfrm>
-            <a:off x="1399031" y="3683325"/>
+            <a:off x="1399031" y="4151376"/>
             <a:ext cx="9987991" cy="160401"/>
           </a:xfrm>
           <a:prstGeom prst="rect">
@@ -23812,7 +23812,7 @@
         </p:nvSpPr>
         <p:spPr>
           <a:xfrm>
-            <a:off x="1399031" y="3902781"/>
+            <a:off x="1399031" y="4370832"/>
             <a:ext cx="9987991" cy="682752"/>
           </a:xfrm>
           <a:prstGeom prst="rect">
@@ -23846,7 +23846,7 @@
         </p:nvSpPr>
         <p:spPr>
           <a:xfrm>
-            <a:off x="530352" y="4823277"/>
+            <a:off x="530352" y="5291328"/>
             <a:ext cx="11130991" cy="1121664"/>
           </a:xfrm>
           <a:prstGeom prst="roundRect">
@@ -23900,7 +23900,7 @@
         </p:nvSpPr>
         <p:spPr>
           <a:xfrm>
-            <a:off x="758952" y="5155509"/>
+            <a:off x="758952" y="5623560"/>
             <a:ext cx="457200" cy="457200"/>
           </a:xfrm>
           <a:prstGeom prst="ellipse">
@@ -23952,7 +23952,7 @@
         </p:blipFill>
         <p:spPr>
           <a:xfrm>
-            <a:off x="868680" y="5265237"/>
+            <a:off x="868680" y="5733288"/>
             <a:ext cx="237744" cy="237744"/>
           </a:xfrm>
           <a:prstGeom prst="rect">
@@ -23968,7 +23968,7 @@
         </p:nvSpPr>
         <p:spPr>
           <a:xfrm>
-            <a:off x="1399031" y="4969581"/>
+            <a:off x="1399031" y="5437632"/>
             <a:ext cx="9987991" cy="160401"/>
           </a:xfrm>
           <a:prstGeom prst="rect">
@@ -24003,7 +24003,7 @@
         </p:nvSpPr>
         <p:spPr>
           <a:xfrm>
-            <a:off x="1399031" y="5189037"/>
+            <a:off x="1399031" y="5657088"/>
             <a:ext cx="9987991" cy="682752"/>
           </a:xfrm>
           <a:prstGeom prst="rect">
@@ -24772,7 +24772,7 @@
                 </a:solidFill>
                 <a:latin typeface="Calibri"/>
               </a:rPr>
-              <a:t>Week 4 Day 4: who is leaving Zomato Gold, and at which step</a:t>
+              <a:t>Week 4, Day 4. Who is leaving Zomato Gold in Chennai, and at which step?</a:t>
             </a:r>
           </a:p>
         </p:txBody>
@@ -28139,7 +28139,7 @@
       </p:sp>
       <p:pic>
         <p:nvPicPr>
-          <p:cNvPr id="9" name="mermaid diagram" descr="77696b2b83291b3e.png"/>
+          <p:cNvPr id="9" name="mermaid diagram" descr="719bb35174f10f2f.png"/>
           <p:cNvPicPr>
             <a:picLocks noChangeAspect="1"/>
           </p:cNvPicPr>
@@ -28153,8 +28153,8 @@
         </p:blipFill>
         <p:spPr>
           <a:xfrm>
-            <a:off x="530352" y="1956816"/>
-            <a:ext cx="11130991" cy="712476"/>
+            <a:off x="530351" y="1956816"/>
+            <a:ext cx="11130991" cy="1096456"/>
           </a:xfrm>
           <a:prstGeom prst="rect">
             <a:avLst/>
@@ -28169,7 +28169,7 @@
         </p:nvSpPr>
         <p:spPr>
           <a:xfrm>
-            <a:off x="530352" y="2815596"/>
+            <a:off x="530352" y="3199576"/>
             <a:ext cx="11130991" cy="1601216"/>
           </a:xfrm>
           <a:prstGeom prst="rect">
@@ -33834,7 +33834,7 @@
       </p:sp>
       <p:pic>
         <p:nvPicPr>
-          <p:cNvPr id="9" name="mermaid diagram" descr="6c03ae8eaa64889d.png"/>
+          <p:cNvPr id="9" name="mermaid diagram" descr="014ba7b686b01944.png"/>
           <p:cNvPicPr>
             <a:picLocks noChangeAspect="1"/>
           </p:cNvPicPr>
@@ -33849,7 +33849,7 @@
         <p:spPr>
           <a:xfrm>
             <a:off x="530352" y="1956816"/>
-            <a:ext cx="11130991" cy="1023688"/>
+            <a:ext cx="11130991" cy="1331913"/>
           </a:xfrm>
           <a:prstGeom prst="rect">
             <a:avLst/>
@@ -33865,7 +33865,7 @@
           <p:nvPr/>
         </p:nvGraphicFramePr>
         <p:xfrm>
-          <a:off x="530352" y="3126808"/>
+          <a:off x="530352" y="3435033"/>
           <a:ext cx="11130991" cy="2218944"/>
         </p:xfrm>
         <a:graphic>
@@ -34673,7 +34673,7 @@
       </p:sp>
       <p:pic>
         <p:nvPicPr>
-          <p:cNvPr id="9" name="mermaid diagram" descr="310bdaed764530a6.png"/>
+          <p:cNvPr id="9" name="mermaid diagram" descr="631100b542aac93e.png"/>
           <p:cNvPicPr>
             <a:picLocks noChangeAspect="1"/>
           </p:cNvPicPr>
@@ -34687,8 +34687,8 @@
         </p:blipFill>
         <p:spPr>
           <a:xfrm>
-            <a:off x="530352" y="1956816"/>
-            <a:ext cx="11130991" cy="1149395"/>
+            <a:off x="530352" y="1830683"/>
+            <a:ext cx="11130991" cy="1962193"/>
           </a:xfrm>
           <a:prstGeom prst="rect">
             <a:avLst/>
@@ -34703,7 +34703,7 @@
         </p:nvSpPr>
         <p:spPr>
           <a:xfrm>
-            <a:off x="530352" y="3252515"/>
+            <a:off x="530352" y="4005072"/>
             <a:ext cx="11130991" cy="1341120"/>
           </a:xfrm>
           <a:prstGeom prst="roundRect">
@@ -34751,7 +34751,7 @@
         </p:nvSpPr>
         <p:spPr>
           <a:xfrm>
-            <a:off x="676656" y="3380531"/>
+            <a:off x="676656" y="4133088"/>
             <a:ext cx="45720" cy="1085088"/>
           </a:xfrm>
           <a:prstGeom prst="roundRect">
@@ -34797,7 +34797,7 @@
         </p:nvSpPr>
         <p:spPr>
           <a:xfrm>
-            <a:off x="877824" y="3371387"/>
+            <a:off x="877824" y="4123944"/>
             <a:ext cx="10564063" cy="1158240"/>
           </a:xfrm>
           <a:prstGeom prst="rect">
@@ -34840,7 +34840,7 @@
         </p:nvSpPr>
         <p:spPr>
           <a:xfrm>
-            <a:off x="530352" y="4758227"/>
+            <a:off x="530352" y="5510784"/>
             <a:ext cx="11130991" cy="1121664"/>
           </a:xfrm>
           <a:prstGeom prst="roundRect">
@@ -34894,7 +34894,7 @@
         </p:nvSpPr>
         <p:spPr>
           <a:xfrm>
-            <a:off x="758952" y="5090459"/>
+            <a:off x="758952" y="5843016"/>
             <a:ext cx="457200" cy="457200"/>
           </a:xfrm>
           <a:prstGeom prst="ellipse">
@@ -34946,7 +34946,7 @@
         </p:blipFill>
         <p:spPr>
           <a:xfrm>
-            <a:off x="868680" y="5200187"/>
+            <a:off x="868680" y="5952744"/>
             <a:ext cx="237744" cy="237744"/>
           </a:xfrm>
           <a:prstGeom prst="rect">
@@ -34962,7 +34962,7 @@
         </p:nvSpPr>
         <p:spPr>
           <a:xfrm>
-            <a:off x="1399031" y="4904531"/>
+            <a:off x="1399031" y="5657088"/>
             <a:ext cx="9987991" cy="160401"/>
           </a:xfrm>
           <a:prstGeom prst="rect">
@@ -34997,7 +34997,7 @@
         </p:nvSpPr>
         <p:spPr>
           <a:xfrm>
-            <a:off x="1399031" y="5123987"/>
+            <a:off x="1399031" y="5876544"/>
             <a:ext cx="9987991" cy="682752"/>
           </a:xfrm>
           <a:prstGeom prst="rect">
@@ -35766,7 +35766,7 @@
                 </a:solidFill>
                 <a:latin typeface="Calibri"/>
               </a:rPr>
-              <a:t>Week 4 Day 4: who is leaving Zomato Gold, and at which step</a:t>
+              <a:t>Week 4, Day 4. Who is leaving Zomato Gold in Chennai, and at which step?</a:t>
             </a:r>
           </a:p>
         </p:txBody>

</xml_diff>